<commit_message>
docs(paper): regenerate the statistics, the PDF and the seminar deck from the edited sources
make stats (counts read back from the tree: Python/TypeScript files and lines, test files,
route modules and declarations, schemas, git revision), then a clean make (80 pages, no
undefined references or citations, no overfull boxes, all Type 1 fonts, abstract 225 words),
and generate_slides.py (the loop table is ten rows). No measured result, benchmark number or
conclusion was touched: the evaluation table is still all "not measured".

Co-Authored-By: Claude Sonnet 5.5 <noreply@anthropic.com>
</commit_message>
<xml_diff>
--- a/paper/slides/caliber-layered-control-plane.pptx
+++ b/paper/slides/caliber-layered-control-plane.pptx
@@ -5729,7 +5729,7 @@
                 </a:solidFill>
                 <a:latin typeface="Calibri"/>
               </a:rPr>
-              <a:t>129k lines of Python,</a:t>
+              <a:t>173k lines of Python,</a:t>
             </a:r>
             <a:br/>
             <a:r>
@@ -5739,7 +5739,7 @@
                 </a:solidFill>
                 <a:latin typeface="Calibri"/>
               </a:rPr>
-              <a:t>177k of TypeScript</a:t>
+              <a:t>210k of TypeScript</a:t>
             </a:r>
           </a:p>
         </p:txBody>
@@ -15337,7 +15337,7 @@
                 </a:solidFill>
                 <a:latin typeface="Calibri"/>
               </a:rPr>
-              <a:t>Nine loops, and no single delivery guarantee</a:t>
+              <a:t>Ten loops, and no single delivery guarantee</a:t>
             </a:r>
           </a:p>
         </p:txBody>
@@ -15589,7 +15589,7 @@
         </p:nvSpPr>
         <p:spPr>
           <a:xfrm>
-            <a:off x="635000" y="2347087"/>
+            <a:off x="635000" y="2309749"/>
             <a:ext cx="10909300" cy="7620"/>
           </a:xfrm>
           <a:prstGeom prst="rect">
@@ -15634,7 +15634,7 @@
         <p:spPr>
           <a:xfrm>
             <a:off x="749300" y="2116074"/>
-            <a:ext cx="1549400" cy="149733"/>
+            <a:ext cx="1549400" cy="112395"/>
           </a:xfrm>
           <a:prstGeom prst="rect">
             <a:avLst/>
@@ -15653,7 +15653,7 @@
               </a:lnSpc>
             </a:pPr>
             <a:r>
-              <a:rPr sz="850" b="0" i="0">
+              <a:rPr sz="750" b="0" i="0">
                 <a:solidFill>
                   <a:srgbClr val="24354F"/>
                 </a:solidFill>
@@ -15673,7 +15673,7 @@
         <p:spPr>
           <a:xfrm>
             <a:off x="2527300" y="2116074"/>
-            <a:ext cx="1041400" cy="149733"/>
+            <a:ext cx="1041400" cy="112395"/>
           </a:xfrm>
           <a:prstGeom prst="rect">
             <a:avLst/>
@@ -15692,7 +15692,7 @@
               </a:lnSpc>
             </a:pPr>
             <a:r>
-              <a:rPr sz="850" b="0" i="0">
+              <a:rPr sz="750" b="0" i="0">
                 <a:solidFill>
                   <a:srgbClr val="24354F"/>
                 </a:solidFill>
@@ -15712,7 +15712,7 @@
         <p:spPr>
           <a:xfrm>
             <a:off x="3797300" y="2116074"/>
-            <a:ext cx="3962400" cy="149733"/>
+            <a:ext cx="3962400" cy="112395"/>
           </a:xfrm>
           <a:prstGeom prst="rect">
             <a:avLst/>
@@ -15731,7 +15731,7 @@
               </a:lnSpc>
             </a:pPr>
             <a:r>
-              <a:rPr sz="850" b="0" i="0">
+              <a:rPr sz="750" b="0" i="0">
                 <a:solidFill>
                   <a:srgbClr val="24354F"/>
                 </a:solidFill>
@@ -15751,7 +15751,7 @@
         <p:spPr>
           <a:xfrm>
             <a:off x="7988300" y="2116074"/>
-            <a:ext cx="3441700" cy="149733"/>
+            <a:ext cx="3441700" cy="112395"/>
           </a:xfrm>
           <a:prstGeom prst="rect">
             <a:avLst/>
@@ -15770,7 +15770,7 @@
               </a:lnSpc>
             </a:pPr>
             <a:r>
-              <a:rPr sz="850" b="0" i="0">
+              <a:rPr sz="750" b="0" i="0">
                 <a:solidFill>
                   <a:srgbClr val="24354F"/>
                 </a:solidFill>
@@ -15789,8 +15789,8 @@
         </p:nvSpPr>
         <p:spPr>
           <a:xfrm>
-            <a:off x="635000" y="2354707"/>
-            <a:ext cx="10909300" cy="454914"/>
+            <a:off x="635000" y="2317369"/>
+            <a:ext cx="10909300" cy="290195"/>
           </a:xfrm>
           <a:prstGeom prst="rect">
             <a:avLst/>
@@ -15833,7 +15833,7 @@
         </p:nvSpPr>
         <p:spPr>
           <a:xfrm>
-            <a:off x="635000" y="2802001"/>
+            <a:off x="635000" y="2599944"/>
             <a:ext cx="10909300" cy="7620"/>
           </a:xfrm>
           <a:prstGeom prst="rect">
@@ -15877,8 +15877,8 @@
         </p:nvSpPr>
         <p:spPr>
           <a:xfrm>
-            <a:off x="749300" y="2443607"/>
-            <a:ext cx="1549400" cy="277114"/>
+            <a:off x="749300" y="2406269"/>
+            <a:ext cx="1549400" cy="112395"/>
           </a:xfrm>
           <a:prstGeom prst="rect">
             <a:avLst/>
@@ -15897,7 +15897,7 @@
               </a:lnSpc>
             </a:pPr>
             <a:r>
-              <a:rPr sz="850" b="0" i="0">
+              <a:rPr sz="750" b="0" i="0">
                 <a:solidFill>
                   <a:srgbClr val="24354F"/>
                 </a:solidFill>
@@ -15916,8 +15916,8 @@
         </p:nvSpPr>
         <p:spPr>
           <a:xfrm>
-            <a:off x="2527300" y="2443607"/>
-            <a:ext cx="1041400" cy="277114"/>
+            <a:off x="2527300" y="2406269"/>
+            <a:ext cx="1041400" cy="112395"/>
           </a:xfrm>
           <a:prstGeom prst="rect">
             <a:avLst/>
@@ -15936,7 +15936,7 @@
               </a:lnSpc>
             </a:pPr>
             <a:r>
-              <a:rPr sz="850" b="0" i="0">
+              <a:rPr sz="750" b="0" i="0">
                 <a:solidFill>
                   <a:srgbClr val="24354F"/>
                 </a:solidFill>
@@ -15955,8 +15955,8 @@
         </p:nvSpPr>
         <p:spPr>
           <a:xfrm>
-            <a:off x="3797300" y="2443607"/>
-            <a:ext cx="3962400" cy="277114"/>
+            <a:off x="3797300" y="2406269"/>
+            <a:ext cx="3962400" cy="112395"/>
           </a:xfrm>
           <a:prstGeom prst="rect">
             <a:avLst/>
@@ -15975,7 +15975,7 @@
               </a:lnSpc>
             </a:pPr>
             <a:r>
-              <a:rPr sz="850" b="0" i="0">
+              <a:rPr sz="750" b="0" i="0">
                 <a:solidFill>
                   <a:srgbClr val="24354F"/>
                 </a:solidFill>
@@ -15994,8 +15994,8 @@
         </p:nvSpPr>
         <p:spPr>
           <a:xfrm>
-            <a:off x="7988300" y="2443607"/>
-            <a:ext cx="3441700" cy="277114"/>
+            <a:off x="7988300" y="2406269"/>
+            <a:ext cx="3441700" cy="112395"/>
           </a:xfrm>
           <a:prstGeom prst="rect">
             <a:avLst/>
@@ -16014,7 +16014,7 @@
               </a:lnSpc>
             </a:pPr>
             <a:r>
-              <a:rPr sz="850" b="0" i="0">
+              <a:rPr sz="750" b="0" i="0">
                 <a:solidFill>
                   <a:srgbClr val="24354F"/>
                 </a:solidFill>
@@ -16033,7 +16033,7 @@
         </p:nvSpPr>
         <p:spPr>
           <a:xfrm>
-            <a:off x="635000" y="3256915"/>
+            <a:off x="635000" y="3002534"/>
             <a:ext cx="10909300" cy="7620"/>
           </a:xfrm>
           <a:prstGeom prst="rect">
@@ -16077,8 +16077,8 @@
         </p:nvSpPr>
         <p:spPr>
           <a:xfrm>
-            <a:off x="749300" y="2898521"/>
-            <a:ext cx="1549400" cy="277114"/>
+            <a:off x="749300" y="2696464"/>
+            <a:ext cx="1549400" cy="224790"/>
           </a:xfrm>
           <a:prstGeom prst="rect">
             <a:avLst/>
@@ -16097,7 +16097,7 @@
               </a:lnSpc>
             </a:pPr>
             <a:r>
-              <a:rPr sz="850" b="0" i="0">
+              <a:rPr sz="750" b="0" i="0">
                 <a:solidFill>
                   <a:srgbClr val="24354F"/>
                 </a:solidFill>
@@ -16116,8 +16116,8 @@
         </p:nvSpPr>
         <p:spPr>
           <a:xfrm>
-            <a:off x="2527300" y="2898521"/>
-            <a:ext cx="1041400" cy="277114"/>
+            <a:off x="2527300" y="2696464"/>
+            <a:ext cx="1041400" cy="224790"/>
           </a:xfrm>
           <a:prstGeom prst="rect">
             <a:avLst/>
@@ -16136,7 +16136,7 @@
               </a:lnSpc>
             </a:pPr>
             <a:r>
-              <a:rPr sz="850" b="1" i="0">
+              <a:rPr sz="750" b="1" i="0">
                 <a:solidFill>
                   <a:srgbClr val="A93B2B"/>
                 </a:solidFill>
@@ -16155,8 +16155,8 @@
         </p:nvSpPr>
         <p:spPr>
           <a:xfrm>
-            <a:off x="3797300" y="2898521"/>
-            <a:ext cx="3962400" cy="277114"/>
+            <a:off x="3797300" y="2696464"/>
+            <a:ext cx="3962400" cy="224790"/>
           </a:xfrm>
           <a:prstGeom prst="rect">
             <a:avLst/>
@@ -16175,7 +16175,7 @@
               </a:lnSpc>
             </a:pPr>
             <a:r>
-              <a:rPr sz="850" b="0" i="0">
+              <a:rPr sz="750" b="0" i="0">
                 <a:solidFill>
                   <a:srgbClr val="24354F"/>
                 </a:solidFill>
@@ -16194,8 +16194,8 @@
         </p:nvSpPr>
         <p:spPr>
           <a:xfrm>
-            <a:off x="7988300" y="2898521"/>
-            <a:ext cx="3441700" cy="277114"/>
+            <a:off x="7988300" y="2696464"/>
+            <a:ext cx="3441700" cy="224790"/>
           </a:xfrm>
           <a:prstGeom prst="rect">
             <a:avLst/>
@@ -16214,7 +16214,7 @@
               </a:lnSpc>
             </a:pPr>
             <a:r>
-              <a:rPr sz="850" b="0" i="0">
+              <a:rPr sz="750" b="0" i="0">
                 <a:solidFill>
                   <a:srgbClr val="24354F"/>
                 </a:solidFill>
@@ -16233,8 +16233,8 @@
         </p:nvSpPr>
         <p:spPr>
           <a:xfrm>
-            <a:off x="635000" y="3264535"/>
-            <a:ext cx="10909300" cy="327533"/>
+            <a:off x="635000" y="3010154"/>
+            <a:ext cx="10909300" cy="290195"/>
           </a:xfrm>
           <a:prstGeom prst="rect">
             <a:avLst/>
@@ -16277,7 +16277,7 @@
         </p:nvSpPr>
         <p:spPr>
           <a:xfrm>
-            <a:off x="635000" y="3584448"/>
+            <a:off x="635000" y="3292729"/>
             <a:ext cx="10909300" cy="7620"/>
           </a:xfrm>
           <a:prstGeom prst="rect">
@@ -16321,8 +16321,8 @@
         </p:nvSpPr>
         <p:spPr>
           <a:xfrm>
-            <a:off x="749300" y="3353435"/>
-            <a:ext cx="1549400" cy="149733"/>
+            <a:off x="749300" y="3099054"/>
+            <a:ext cx="1549400" cy="112395"/>
           </a:xfrm>
           <a:prstGeom prst="rect">
             <a:avLst/>
@@ -16341,7 +16341,7 @@
               </a:lnSpc>
             </a:pPr>
             <a:r>
-              <a:rPr sz="850" b="0" i="0">
+              <a:rPr sz="750" b="0" i="0">
                 <a:solidFill>
                   <a:srgbClr val="24354F"/>
                 </a:solidFill>
@@ -16360,8 +16360,8 @@
         </p:nvSpPr>
         <p:spPr>
           <a:xfrm>
-            <a:off x="2527300" y="3353435"/>
-            <a:ext cx="1041400" cy="149733"/>
+            <a:off x="2527300" y="3099054"/>
+            <a:ext cx="1041400" cy="112395"/>
           </a:xfrm>
           <a:prstGeom prst="rect">
             <a:avLst/>
@@ -16380,7 +16380,7 @@
               </a:lnSpc>
             </a:pPr>
             <a:r>
-              <a:rPr sz="850" b="0" i="0">
+              <a:rPr sz="750" b="0" i="0">
                 <a:solidFill>
                   <a:srgbClr val="24354F"/>
                 </a:solidFill>
@@ -16399,8 +16399,8 @@
         </p:nvSpPr>
         <p:spPr>
           <a:xfrm>
-            <a:off x="3797300" y="3353435"/>
-            <a:ext cx="3962400" cy="149733"/>
+            <a:off x="3797300" y="3099054"/>
+            <a:ext cx="3962400" cy="112395"/>
           </a:xfrm>
           <a:prstGeom prst="rect">
             <a:avLst/>
@@ -16419,7 +16419,7 @@
               </a:lnSpc>
             </a:pPr>
             <a:r>
-              <a:rPr sz="850" b="0" i="0">
+              <a:rPr sz="750" b="0" i="0">
                 <a:solidFill>
                   <a:srgbClr val="24354F"/>
                 </a:solidFill>
@@ -16438,8 +16438,8 @@
         </p:nvSpPr>
         <p:spPr>
           <a:xfrm>
-            <a:off x="7988300" y="3353435"/>
-            <a:ext cx="3441700" cy="149733"/>
+            <a:off x="7988300" y="3099054"/>
+            <a:ext cx="3441700" cy="112395"/>
           </a:xfrm>
           <a:prstGeom prst="rect">
             <a:avLst/>
@@ -16458,7 +16458,7 @@
               </a:lnSpc>
             </a:pPr>
             <a:r>
-              <a:rPr sz="850" b="0" i="0">
+              <a:rPr sz="750" b="0" i="0">
                 <a:solidFill>
                   <a:srgbClr val="24354F"/>
                 </a:solidFill>
@@ -16477,7 +16477,7 @@
         </p:nvSpPr>
         <p:spPr>
           <a:xfrm>
-            <a:off x="635000" y="3911981"/>
+            <a:off x="635000" y="3582924"/>
             <a:ext cx="10909300" cy="7620"/>
           </a:xfrm>
           <a:prstGeom prst="rect">
@@ -16521,8 +16521,8 @@
         </p:nvSpPr>
         <p:spPr>
           <a:xfrm>
-            <a:off x="749300" y="3680968"/>
-            <a:ext cx="1549400" cy="149733"/>
+            <a:off x="749300" y="3389249"/>
+            <a:ext cx="1549400" cy="112395"/>
           </a:xfrm>
           <a:prstGeom prst="rect">
             <a:avLst/>
@@ -16541,7 +16541,7 @@
               </a:lnSpc>
             </a:pPr>
             <a:r>
-              <a:rPr sz="850" b="0" i="0">
+              <a:rPr sz="750" b="0" i="0">
                 <a:solidFill>
                   <a:srgbClr val="24354F"/>
                 </a:solidFill>
@@ -16560,8 +16560,8 @@
         </p:nvSpPr>
         <p:spPr>
           <a:xfrm>
-            <a:off x="2527300" y="3680968"/>
-            <a:ext cx="1041400" cy="149733"/>
+            <a:off x="2527300" y="3389249"/>
+            <a:ext cx="1041400" cy="112395"/>
           </a:xfrm>
           <a:prstGeom prst="rect">
             <a:avLst/>
@@ -16580,7 +16580,7 @@
               </a:lnSpc>
             </a:pPr>
             <a:r>
-              <a:rPr sz="850" b="0" i="0">
+              <a:rPr sz="750" b="0" i="0">
                 <a:solidFill>
                   <a:srgbClr val="24354F"/>
                 </a:solidFill>
@@ -16599,8 +16599,8 @@
         </p:nvSpPr>
         <p:spPr>
           <a:xfrm>
-            <a:off x="3797300" y="3680968"/>
-            <a:ext cx="3962400" cy="149733"/>
+            <a:off x="3797300" y="3389249"/>
+            <a:ext cx="3962400" cy="112395"/>
           </a:xfrm>
           <a:prstGeom prst="rect">
             <a:avLst/>
@@ -16619,7 +16619,7 @@
               </a:lnSpc>
             </a:pPr>
             <a:r>
-              <a:rPr sz="850" b="0" i="0">
+              <a:rPr sz="750" b="0" i="0">
                 <a:solidFill>
                   <a:srgbClr val="24354F"/>
                 </a:solidFill>
@@ -16638,8 +16638,8 @@
         </p:nvSpPr>
         <p:spPr>
           <a:xfrm>
-            <a:off x="7988300" y="3680968"/>
-            <a:ext cx="3441700" cy="149733"/>
+            <a:off x="7988300" y="3389249"/>
+            <a:ext cx="3441700" cy="112395"/>
           </a:xfrm>
           <a:prstGeom prst="rect">
             <a:avLst/>
@@ -16658,7 +16658,7 @@
               </a:lnSpc>
             </a:pPr>
             <a:r>
-              <a:rPr sz="850" b="0" i="0">
+              <a:rPr sz="750" b="0" i="0">
                 <a:solidFill>
                   <a:srgbClr val="24354F"/>
                 </a:solidFill>
@@ -16677,8 +16677,8 @@
         </p:nvSpPr>
         <p:spPr>
           <a:xfrm>
-            <a:off x="635000" y="3919601"/>
-            <a:ext cx="10909300" cy="327533"/>
+            <a:off x="635000" y="3590544"/>
+            <a:ext cx="10909300" cy="290195"/>
           </a:xfrm>
           <a:prstGeom prst="rect">
             <a:avLst/>
@@ -16721,7 +16721,7 @@
         </p:nvSpPr>
         <p:spPr>
           <a:xfrm>
-            <a:off x="635000" y="4239514"/>
+            <a:off x="635000" y="3873119"/>
             <a:ext cx="10909300" cy="7620"/>
           </a:xfrm>
           <a:prstGeom prst="rect">
@@ -16765,8 +16765,8 @@
         </p:nvSpPr>
         <p:spPr>
           <a:xfrm>
-            <a:off x="749300" y="4008501"/>
-            <a:ext cx="1549400" cy="149733"/>
+            <a:off x="749300" y="3679444"/>
+            <a:ext cx="1549400" cy="112395"/>
           </a:xfrm>
           <a:prstGeom prst="rect">
             <a:avLst/>
@@ -16785,13 +16785,13 @@
               </a:lnSpc>
             </a:pPr>
             <a:r>
-              <a:rPr sz="850" b="0" i="0">
+              <a:rPr sz="750" b="0" i="0">
                 <a:solidFill>
                   <a:srgbClr val="24354F"/>
                 </a:solidFill>
                 <a:latin typeface="Calibri"/>
               </a:rPr>
-              <a:t>WorkflowScheduler</a:t>
+              <a:t>WorkspaceImport</a:t>
             </a:r>
           </a:p>
         </p:txBody>
@@ -16804,8 +16804,8 @@
         </p:nvSpPr>
         <p:spPr>
           <a:xfrm>
-            <a:off x="2527300" y="4008501"/>
-            <a:ext cx="1041400" cy="149733"/>
+            <a:off x="2527300" y="3679444"/>
+            <a:ext cx="1041400" cy="112395"/>
           </a:xfrm>
           <a:prstGeom prst="rect">
             <a:avLst/>
@@ -16824,13 +16824,13 @@
               </a:lnSpc>
             </a:pPr>
             <a:r>
-              <a:rPr sz="850" b="1" i="0">
-                <a:solidFill>
-                  <a:srgbClr val="A93B2B"/>
-                </a:solidFill>
-                <a:latin typeface="Calibri"/>
-              </a:rPr>
-              <a:t>none</a:t>
+              <a:rPr sz="750" b="0" i="0">
+                <a:solidFill>
+                  <a:srgbClr val="24354F"/>
+                </a:solidFill>
+                <a:latin typeface="Calibri"/>
+              </a:rPr>
+              <a:t>claim + heartbeat</a:t>
             </a:r>
           </a:p>
         </p:txBody>
@@ -16843,8 +16843,8 @@
         </p:nvSpPr>
         <p:spPr>
           <a:xfrm>
-            <a:off x="3797300" y="4008501"/>
-            <a:ext cx="3962400" cy="149733"/>
+            <a:off x="3797300" y="3679444"/>
+            <a:ext cx="3962400" cy="112395"/>
           </a:xfrm>
           <a:prstGeom prst="rect">
             <a:avLst/>
@@ -16863,13 +16863,13 @@
               </a:lnSpc>
             </a:pPr>
             <a:r>
-              <a:rPr sz="850" b="0" i="0">
+              <a:rPr sz="750" b="0" i="0">
                 <a:solidFill>
                   <a:srgbClr val="24354F"/>
                 </a:solidFill>
                 <a:latin typeface="Calibri"/>
               </a:rPr>
-              <a:t>idempotent by a minute-bucketed key behind a unique partial index</a:t>
+              <a:t>lease expiry marks the job for reconciliation, not requeued automatically</a:t>
             </a:r>
           </a:p>
         </p:txBody>
@@ -16882,8 +16882,8 @@
         </p:nvSpPr>
         <p:spPr>
           <a:xfrm>
-            <a:off x="7988300" y="4008501"/>
-            <a:ext cx="3441700" cy="149733"/>
+            <a:off x="7988300" y="3679444"/>
+            <a:ext cx="3441700" cy="112395"/>
           </a:xfrm>
           <a:prstGeom prst="rect">
             <a:avLst/>
@@ -16902,13 +16902,13 @@
               </a:lnSpc>
             </a:pPr>
             <a:r>
-              <a:rPr sz="850" b="0" i="0">
+              <a:rPr sz="750" b="0" i="0">
                 <a:solidFill>
                   <a:srgbClr val="24354F"/>
                 </a:solidFill>
                 <a:latin typeface="Calibri"/>
               </a:rPr>
-              <a:t>exactly-once firing; the work it enqueues then follows WorkflowRun</a:t>
+              <a:t>at-most-once per attempt; a retry safely replays the committed revision</a:t>
             </a:r>
           </a:p>
         </p:txBody>
@@ -16921,7 +16921,7 @@
         </p:nvSpPr>
         <p:spPr>
           <a:xfrm>
-            <a:off x="635000" y="4567047"/>
+            <a:off x="635000" y="4163314"/>
             <a:ext cx="10909300" cy="7620"/>
           </a:xfrm>
           <a:prstGeom prst="rect">
@@ -16965,8 +16965,8 @@
         </p:nvSpPr>
         <p:spPr>
           <a:xfrm>
-            <a:off x="749300" y="4336034"/>
-            <a:ext cx="1549400" cy="149733"/>
+            <a:off x="749300" y="3969639"/>
+            <a:ext cx="1549400" cy="112395"/>
           </a:xfrm>
           <a:prstGeom prst="rect">
             <a:avLst/>
@@ -16985,13 +16985,13 @@
               </a:lnSpc>
             </a:pPr>
             <a:r>
-              <a:rPr sz="850" b="0" i="0">
+              <a:rPr sz="750" b="0" i="0">
                 <a:solidFill>
                   <a:srgbClr val="24354F"/>
                 </a:solidFill>
                 <a:latin typeface="Calibri"/>
               </a:rPr>
-              <a:t>Janitor</a:t>
+              <a:t>WorkflowScheduler</a:t>
             </a:r>
           </a:p>
         </p:txBody>
@@ -17004,8 +17004,8 @@
         </p:nvSpPr>
         <p:spPr>
           <a:xfrm>
-            <a:off x="2527300" y="4336034"/>
-            <a:ext cx="1041400" cy="149733"/>
+            <a:off x="2527300" y="3969639"/>
+            <a:ext cx="1041400" cy="112395"/>
           </a:xfrm>
           <a:prstGeom prst="rect">
             <a:avLst/>
@@ -17024,7 +17024,7 @@
               </a:lnSpc>
             </a:pPr>
             <a:r>
-              <a:rPr sz="850" b="1" i="0">
+              <a:rPr sz="750" b="1" i="0">
                 <a:solidFill>
                   <a:srgbClr val="A93B2B"/>
                 </a:solidFill>
@@ -17043,8 +17043,8 @@
         </p:nvSpPr>
         <p:spPr>
           <a:xfrm>
-            <a:off x="3797300" y="4336034"/>
-            <a:ext cx="3962400" cy="149733"/>
+            <a:off x="3797300" y="3969639"/>
+            <a:ext cx="3962400" cy="112395"/>
           </a:xfrm>
           <a:prstGeom prst="rect">
             <a:avLst/>
@@ -17063,13 +17063,13 @@
               </a:lnSpc>
             </a:pPr>
             <a:r>
-              <a:rPr sz="850" b="0" i="0">
+              <a:rPr sz="750" b="0" i="0">
                 <a:solidFill>
                   <a:srgbClr val="24354F"/>
                 </a:solidFill>
                 <a:latin typeface="Calibri"/>
               </a:rPr>
-              <a:t>an idempotent sweep; repeating it changes nothing</a:t>
+              <a:t>idempotent by a minute-bucketed key behind a unique partial index</a:t>
             </a:r>
           </a:p>
         </p:txBody>
@@ -17082,8 +17082,8 @@
         </p:nvSpPr>
         <p:spPr>
           <a:xfrm>
-            <a:off x="7988300" y="4336034"/>
-            <a:ext cx="3441700" cy="149733"/>
+            <a:off x="7988300" y="3969639"/>
+            <a:ext cx="3441700" cy="112395"/>
           </a:xfrm>
           <a:prstGeom prst="rect">
             <a:avLst/>
@@ -17102,13 +17102,13 @@
               </a:lnSpc>
             </a:pPr>
             <a:r>
-              <a:rPr sz="850" b="0" i="0">
+              <a:rPr sz="750" b="0" i="0">
                 <a:solidFill>
                   <a:srgbClr val="24354F"/>
                 </a:solidFill>
                 <a:latin typeface="Calibri"/>
               </a:rPr>
-              <a:t>idempotent</a:t>
+              <a:t>exactly-once firing; the work it enqueues then follows WorkflowRun</a:t>
             </a:r>
           </a:p>
         </p:txBody>
@@ -17121,8 +17121,8 @@
         </p:nvSpPr>
         <p:spPr>
           <a:xfrm>
-            <a:off x="635000" y="4574667"/>
-            <a:ext cx="10909300" cy="327533"/>
+            <a:off x="635000" y="4170934"/>
+            <a:ext cx="10909300" cy="290195"/>
           </a:xfrm>
           <a:prstGeom prst="rect">
             <a:avLst/>
@@ -17165,7 +17165,7 @@
         </p:nvSpPr>
         <p:spPr>
           <a:xfrm>
-            <a:off x="635000" y="4894580"/>
+            <a:off x="635000" y="4453509"/>
             <a:ext cx="10909300" cy="7620"/>
           </a:xfrm>
           <a:prstGeom prst="rect">
@@ -17209,8 +17209,8 @@
         </p:nvSpPr>
         <p:spPr>
           <a:xfrm>
-            <a:off x="749300" y="4663567"/>
-            <a:ext cx="1549400" cy="149733"/>
+            <a:off x="749300" y="4259834"/>
+            <a:ext cx="1549400" cy="112395"/>
           </a:xfrm>
           <a:prstGeom prst="rect">
             <a:avLst/>
@@ -17229,12 +17229,212 @@
               </a:lnSpc>
             </a:pPr>
             <a:r>
-              <a:rPr sz="850" b="0" i="0">
+              <a:rPr sz="750" b="0" i="0">
                 <a:solidFill>
                   <a:srgbClr val="24354F"/>
                 </a:solidFill>
                 <a:latin typeface="Calibri"/>
               </a:rPr>
+              <a:t>Janitor</a:t>
+            </a:r>
+          </a:p>
+        </p:txBody>
+      </p:sp>
+      <p:sp>
+        <p:nvSpPr>
+          <p:cNvPr id="53" name="TextBox 52"/>
+          <p:cNvSpPr txBox="1"/>
+          <p:nvPr/>
+        </p:nvSpPr>
+        <p:spPr>
+          <a:xfrm>
+            <a:off x="2527300" y="4259834"/>
+            <a:ext cx="1041400" cy="112395"/>
+          </a:xfrm>
+          <a:prstGeom prst="rect">
+            <a:avLst/>
+          </a:prstGeom>
+          <a:noFill/>
+        </p:spPr>
+        <p:txBody>
+          <a:bodyPr wrap="square" lIns="0" rIns="0" tIns="0" bIns="0" anchor="ctr">
+            <a:spAutoFit/>
+          </a:bodyPr>
+          <a:lstStyle/>
+          <a:p>
+            <a:pPr algn="l">
+              <a:lnSpc>
+                <a:spcPct val="118000"/>
+              </a:lnSpc>
+            </a:pPr>
+            <a:r>
+              <a:rPr sz="750" b="1" i="0">
+                <a:solidFill>
+                  <a:srgbClr val="A93B2B"/>
+                </a:solidFill>
+                <a:latin typeface="Calibri"/>
+              </a:rPr>
+              <a:t>none</a:t>
+            </a:r>
+          </a:p>
+        </p:txBody>
+      </p:sp>
+      <p:sp>
+        <p:nvSpPr>
+          <p:cNvPr id="54" name="TextBox 53"/>
+          <p:cNvSpPr txBox="1"/>
+          <p:nvPr/>
+        </p:nvSpPr>
+        <p:spPr>
+          <a:xfrm>
+            <a:off x="3797300" y="4259834"/>
+            <a:ext cx="3962400" cy="112395"/>
+          </a:xfrm>
+          <a:prstGeom prst="rect">
+            <a:avLst/>
+          </a:prstGeom>
+          <a:noFill/>
+        </p:spPr>
+        <p:txBody>
+          <a:bodyPr wrap="square" lIns="0" rIns="0" tIns="0" bIns="0" anchor="ctr">
+            <a:spAutoFit/>
+          </a:bodyPr>
+          <a:lstStyle/>
+          <a:p>
+            <a:pPr algn="l">
+              <a:lnSpc>
+                <a:spcPct val="118000"/>
+              </a:lnSpc>
+            </a:pPr>
+            <a:r>
+              <a:rPr sz="750" b="0" i="0">
+                <a:solidFill>
+                  <a:srgbClr val="24354F"/>
+                </a:solidFill>
+                <a:latin typeface="Calibri"/>
+              </a:rPr>
+              <a:t>an idempotent sweep; repeating it changes nothing</a:t>
+            </a:r>
+          </a:p>
+        </p:txBody>
+      </p:sp>
+      <p:sp>
+        <p:nvSpPr>
+          <p:cNvPr id="55" name="TextBox 54"/>
+          <p:cNvSpPr txBox="1"/>
+          <p:nvPr/>
+        </p:nvSpPr>
+        <p:spPr>
+          <a:xfrm>
+            <a:off x="7988300" y="4259834"/>
+            <a:ext cx="3441700" cy="112395"/>
+          </a:xfrm>
+          <a:prstGeom prst="rect">
+            <a:avLst/>
+          </a:prstGeom>
+          <a:noFill/>
+        </p:spPr>
+        <p:txBody>
+          <a:bodyPr wrap="square" lIns="0" rIns="0" tIns="0" bIns="0" anchor="ctr">
+            <a:spAutoFit/>
+          </a:bodyPr>
+          <a:lstStyle/>
+          <a:p>
+            <a:pPr algn="l">
+              <a:lnSpc>
+                <a:spcPct val="118000"/>
+              </a:lnSpc>
+            </a:pPr>
+            <a:r>
+              <a:rPr sz="750" b="0" i="0">
+                <a:solidFill>
+                  <a:srgbClr val="24354F"/>
+                </a:solidFill>
+                <a:latin typeface="Calibri"/>
+              </a:rPr>
+              <a:t>idempotent</a:t>
+            </a:r>
+          </a:p>
+        </p:txBody>
+      </p:sp>
+      <p:sp>
+        <p:nvSpPr>
+          <p:cNvPr id="56" name="Rectangle 55"/>
+          <p:cNvSpPr/>
+          <p:nvPr/>
+        </p:nvSpPr>
+        <p:spPr>
+          <a:xfrm>
+            <a:off x="635000" y="4743704"/>
+            <a:ext cx="10909300" cy="7620"/>
+          </a:xfrm>
+          <a:prstGeom prst="rect">
+            <a:avLst/>
+          </a:prstGeom>
+          <a:solidFill>
+            <a:srgbClr val="D5E0EB"/>
+          </a:solidFill>
+          <a:ln>
+            <a:noFill/>
+          </a:ln>
+          <a:effectLst/>
+        </p:spPr>
+        <p:style>
+          <a:lnRef idx="1">
+            <a:schemeClr val="accent1"/>
+          </a:lnRef>
+          <a:fillRef idx="3">
+            <a:schemeClr val="accent1"/>
+          </a:fillRef>
+          <a:effectRef idx="2">
+            <a:schemeClr val="accent1"/>
+          </a:effectRef>
+          <a:fontRef idx="minor">
+            <a:schemeClr val="lt1"/>
+          </a:fontRef>
+        </p:style>
+        <p:txBody>
+          <a:bodyPr rtlCol="0" anchor="ctr"/>
+          <a:lstStyle/>
+          <a:p>
+            <a:pPr algn="ctr"/>
+          </a:p>
+        </p:txBody>
+      </p:sp>
+      <p:sp>
+        <p:nvSpPr>
+          <p:cNvPr id="57" name="TextBox 56"/>
+          <p:cNvSpPr txBox="1"/>
+          <p:nvPr/>
+        </p:nvSpPr>
+        <p:spPr>
+          <a:xfrm>
+            <a:off x="749300" y="4550029"/>
+            <a:ext cx="1549400" cy="112395"/>
+          </a:xfrm>
+          <a:prstGeom prst="rect">
+            <a:avLst/>
+          </a:prstGeom>
+          <a:noFill/>
+        </p:spPr>
+        <p:txBody>
+          <a:bodyPr wrap="square" lIns="0" rIns="0" tIns="0" bIns="0" anchor="ctr">
+            <a:spAutoFit/>
+          </a:bodyPr>
+          <a:lstStyle/>
+          <a:p>
+            <a:pPr algn="l">
+              <a:lnSpc>
+                <a:spcPct val="118000"/>
+              </a:lnSpc>
+            </a:pPr>
+            <a:r>
+              <a:rPr sz="750" b="0" i="0">
+                <a:solidFill>
+                  <a:srgbClr val="24354F"/>
+                </a:solidFill>
+                <a:latin typeface="Calibri"/>
+              </a:rPr>
               <a:t>AriaPlan</a:t>
             </a:r>
           </a:p>
@@ -17242,14 +17442,14 @@
       </p:sp>
       <p:sp>
         <p:nvSpPr>
-          <p:cNvPr id="53" name="TextBox 52"/>
-          <p:cNvSpPr txBox="1"/>
-          <p:nvPr/>
-        </p:nvSpPr>
-        <p:spPr>
-          <a:xfrm>
-            <a:off x="2527300" y="4663567"/>
-            <a:ext cx="1041400" cy="149733"/>
+          <p:cNvPr id="58" name="TextBox 57"/>
+          <p:cNvSpPr txBox="1"/>
+          <p:nvPr/>
+        </p:nvSpPr>
+        <p:spPr>
+          <a:xfrm>
+            <a:off x="2527300" y="4550029"/>
+            <a:ext cx="1041400" cy="112395"/>
           </a:xfrm>
           <a:prstGeom prst="rect">
             <a:avLst/>
@@ -17268,7 +17468,7 @@
               </a:lnSpc>
             </a:pPr>
             <a:r>
-              <a:rPr sz="850" b="1" i="0">
+              <a:rPr sz="750" b="1" i="0">
                 <a:solidFill>
                   <a:srgbClr val="A93B2B"/>
                 </a:solidFill>
@@ -17281,14 +17481,14 @@
       </p:sp>
       <p:sp>
         <p:nvSpPr>
-          <p:cNvPr id="54" name="TextBox 53"/>
-          <p:cNvSpPr txBox="1"/>
-          <p:nvPr/>
-        </p:nvSpPr>
-        <p:spPr>
-          <a:xfrm>
-            <a:off x="3797300" y="4663567"/>
-            <a:ext cx="3962400" cy="149733"/>
+          <p:cNvPr id="59" name="TextBox 58"/>
+          <p:cNvSpPr txBox="1"/>
+          <p:nvPr/>
+        </p:nvSpPr>
+        <p:spPr>
+          <a:xfrm>
+            <a:off x="3797300" y="4550029"/>
+            <a:ext cx="3962400" cy="112395"/>
           </a:xfrm>
           <a:prstGeom prst="rect">
             <a:avLst/>
@@ -17307,7 +17507,7 @@
               </a:lnSpc>
             </a:pPr>
             <a:r>
-              <a:rPr sz="850" b="0" i="0">
+              <a:rPr sz="750" b="0" i="0">
                 <a:solidFill>
                   <a:srgbClr val="24354F"/>
                 </a:solidFill>
@@ -17320,14 +17520,14 @@
       </p:sp>
       <p:sp>
         <p:nvSpPr>
-          <p:cNvPr id="55" name="TextBox 54"/>
-          <p:cNvSpPr txBox="1"/>
-          <p:nvPr/>
-        </p:nvSpPr>
-        <p:spPr>
-          <a:xfrm>
-            <a:off x="7988300" y="4663567"/>
-            <a:ext cx="3441700" cy="149733"/>
+          <p:cNvPr id="60" name="TextBox 59"/>
+          <p:cNvSpPr txBox="1"/>
+          <p:nvPr/>
+        </p:nvSpPr>
+        <p:spPr>
+          <a:xfrm>
+            <a:off x="7988300" y="4550029"/>
+            <a:ext cx="3441700" cy="112395"/>
           </a:xfrm>
           <a:prstGeom prst="rect">
             <a:avLst/>
@@ -17346,7 +17546,7 @@
               </a:lnSpc>
             </a:pPr>
             <a:r>
-              <a:rPr sz="850" b="0" i="0">
+              <a:rPr sz="750" b="0" i="0">
                 <a:solidFill>
                   <a:srgbClr val="24354F"/>
                 </a:solidFill>
@@ -17359,13 +17559,257 @@
       </p:sp>
       <p:sp>
         <p:nvSpPr>
-          <p:cNvPr id="56" name="Rounded Rectangle 55"/>
+          <p:cNvPr id="61" name="Rectangle 60"/>
           <p:cNvSpPr/>
           <p:nvPr/>
         </p:nvSpPr>
         <p:spPr>
           <a:xfrm>
-            <a:off x="635000" y="5080000"/>
+            <a:off x="635000" y="4751324"/>
+            <a:ext cx="10909300" cy="290195"/>
+          </a:xfrm>
+          <a:prstGeom prst="rect">
+            <a:avLst/>
+          </a:prstGeom>
+          <a:solidFill>
+            <a:srgbClr val="F5F9FC"/>
+          </a:solidFill>
+          <a:ln>
+            <a:noFill/>
+          </a:ln>
+          <a:effectLst/>
+        </p:spPr>
+        <p:style>
+          <a:lnRef idx="1">
+            <a:schemeClr val="accent1"/>
+          </a:lnRef>
+          <a:fillRef idx="3">
+            <a:schemeClr val="accent1"/>
+          </a:fillRef>
+          <a:effectRef idx="2">
+            <a:schemeClr val="accent1"/>
+          </a:effectRef>
+          <a:fontRef idx="minor">
+            <a:schemeClr val="lt1"/>
+          </a:fontRef>
+        </p:style>
+        <p:txBody>
+          <a:bodyPr rtlCol="0" anchor="ctr"/>
+          <a:lstStyle/>
+          <a:p>
+            <a:pPr algn="ctr"/>
+          </a:p>
+        </p:txBody>
+      </p:sp>
+      <p:sp>
+        <p:nvSpPr>
+          <p:cNvPr id="62" name="Rectangle 61"/>
+          <p:cNvSpPr/>
+          <p:nvPr/>
+        </p:nvSpPr>
+        <p:spPr>
+          <a:xfrm>
+            <a:off x="635000" y="5033899"/>
+            <a:ext cx="10909300" cy="7620"/>
+          </a:xfrm>
+          <a:prstGeom prst="rect">
+            <a:avLst/>
+          </a:prstGeom>
+          <a:solidFill>
+            <a:srgbClr val="D5E0EB"/>
+          </a:solidFill>
+          <a:ln>
+            <a:noFill/>
+          </a:ln>
+          <a:effectLst/>
+        </p:spPr>
+        <p:style>
+          <a:lnRef idx="1">
+            <a:schemeClr val="accent1"/>
+          </a:lnRef>
+          <a:fillRef idx="3">
+            <a:schemeClr val="accent1"/>
+          </a:fillRef>
+          <a:effectRef idx="2">
+            <a:schemeClr val="accent1"/>
+          </a:effectRef>
+          <a:fontRef idx="minor">
+            <a:schemeClr val="lt1"/>
+          </a:fontRef>
+        </p:style>
+        <p:txBody>
+          <a:bodyPr rtlCol="0" anchor="ctr"/>
+          <a:lstStyle/>
+          <a:p>
+            <a:pPr algn="ctr"/>
+          </a:p>
+        </p:txBody>
+      </p:sp>
+      <p:sp>
+        <p:nvSpPr>
+          <p:cNvPr id="63" name="TextBox 62"/>
+          <p:cNvSpPr txBox="1"/>
+          <p:nvPr/>
+        </p:nvSpPr>
+        <p:spPr>
+          <a:xfrm>
+            <a:off x="749300" y="4840224"/>
+            <a:ext cx="1549400" cy="112395"/>
+          </a:xfrm>
+          <a:prstGeom prst="rect">
+            <a:avLst/>
+          </a:prstGeom>
+          <a:noFill/>
+        </p:spPr>
+        <p:txBody>
+          <a:bodyPr wrap="square" lIns="0" rIns="0" tIns="0" bIns="0" anchor="ctr">
+            <a:spAutoFit/>
+          </a:bodyPr>
+          <a:lstStyle/>
+          <a:p>
+            <a:pPr algn="l">
+              <a:lnSpc>
+                <a:spcPct val="118000"/>
+              </a:lnSpc>
+            </a:pPr>
+            <a:r>
+              <a:rPr sz="750" b="0" i="0">
+                <a:solidFill>
+                  <a:srgbClr val="24354F"/>
+                </a:solidFill>
+                <a:latin typeface="Calibri"/>
+              </a:rPr>
+              <a:t>ReleaseReconciler</a:t>
+            </a:r>
+          </a:p>
+        </p:txBody>
+      </p:sp>
+      <p:sp>
+        <p:nvSpPr>
+          <p:cNvPr id="64" name="TextBox 63"/>
+          <p:cNvSpPr txBox="1"/>
+          <p:nvPr/>
+        </p:nvSpPr>
+        <p:spPr>
+          <a:xfrm>
+            <a:off x="2527300" y="4840224"/>
+            <a:ext cx="1041400" cy="112395"/>
+          </a:xfrm>
+          <a:prstGeom prst="rect">
+            <a:avLst/>
+          </a:prstGeom>
+          <a:noFill/>
+        </p:spPr>
+        <p:txBody>
+          <a:bodyPr wrap="square" lIns="0" rIns="0" tIns="0" bIns="0" anchor="ctr">
+            <a:spAutoFit/>
+          </a:bodyPr>
+          <a:lstStyle/>
+          <a:p>
+            <a:pPr algn="l">
+              <a:lnSpc>
+                <a:spcPct val="118000"/>
+              </a:lnSpc>
+            </a:pPr>
+            <a:r>
+              <a:rPr sz="750" b="1" i="0">
+                <a:solidFill>
+                  <a:srgbClr val="A93B2B"/>
+                </a:solidFill>
+                <a:latin typeface="Calibri"/>
+              </a:rPr>
+              <a:t>none</a:t>
+            </a:r>
+          </a:p>
+        </p:txBody>
+      </p:sp>
+      <p:sp>
+        <p:nvSpPr>
+          <p:cNvPr id="65" name="TextBox 64"/>
+          <p:cNvSpPr txBox="1"/>
+          <p:nvPr/>
+        </p:nvSpPr>
+        <p:spPr>
+          <a:xfrm>
+            <a:off x="3797300" y="4840224"/>
+            <a:ext cx="3962400" cy="112395"/>
+          </a:xfrm>
+          <a:prstGeom prst="rect">
+            <a:avLst/>
+          </a:prstGeom>
+          <a:noFill/>
+        </p:spPr>
+        <p:txBody>
+          <a:bodyPr wrap="square" lIns="0" rIns="0" tIns="0" bIns="0" anchor="ctr">
+            <a:spAutoFit/>
+          </a:bodyPr>
+          <a:lstStyle/>
+          <a:p>
+            <a:pPr algn="l">
+              <a:lnSpc>
+                <a:spcPct val="118000"/>
+              </a:lnSpc>
+            </a:pPr>
+            <a:r>
+              <a:rPr sz="750" b="0" i="0">
+                <a:solidFill>
+                  <a:srgbClr val="24354F"/>
+                </a:solidFill>
+                <a:latin typeface="Calibri"/>
+              </a:rPr>
+              <a:t>none needed: the next tick re-observes the alias; prepared rows are never touched</a:t>
+            </a:r>
+          </a:p>
+        </p:txBody>
+      </p:sp>
+      <p:sp>
+        <p:nvSpPr>
+          <p:cNvPr id="66" name="TextBox 65"/>
+          <p:cNvSpPr txBox="1"/>
+          <p:nvPr/>
+        </p:nvSpPr>
+        <p:spPr>
+          <a:xfrm>
+            <a:off x="7988300" y="4840224"/>
+            <a:ext cx="3441700" cy="112395"/>
+          </a:xfrm>
+          <a:prstGeom prst="rect">
+            <a:avLst/>
+          </a:prstGeom>
+          <a:noFill/>
+        </p:spPr>
+        <p:txBody>
+          <a:bodyPr wrap="square" lIns="0" rIns="0" tIns="0" bIns="0" anchor="ctr">
+            <a:spAutoFit/>
+          </a:bodyPr>
+          <a:lstStyle/>
+          <a:p>
+            <a:pPr algn="l">
+              <a:lnSpc>
+                <a:spcPct val="118000"/>
+              </a:lnSpc>
+            </a:pPr>
+            <a:r>
+              <a:rPr sz="750" b="0" i="0">
+                <a:solidFill>
+                  <a:srgbClr val="24354F"/>
+                </a:solidFill>
+                <a:latin typeface="Calibri"/>
+              </a:rPr>
+              <a:t>idempotent convergence</a:t>
+            </a:r>
+          </a:p>
+        </p:txBody>
+      </p:sp>
+      <p:sp>
+        <p:nvSpPr>
+          <p:cNvPr id="67" name="Rounded Rectangle 66"/>
+          <p:cNvSpPr/>
+          <p:nvPr/>
+        </p:nvSpPr>
+        <p:spPr>
+          <a:xfrm>
+            <a:off x="635000" y="5219319"/>
             <a:ext cx="10909300" cy="909319"/>
           </a:xfrm>
           <a:prstGeom prst="roundRect">
@@ -17405,13 +17849,13 @@
       </p:sp>
       <p:sp>
         <p:nvSpPr>
-          <p:cNvPr id="57" name="TextBox 56"/>
-          <p:cNvSpPr txBox="1"/>
-          <p:nvPr/>
-        </p:nvSpPr>
-        <p:spPr>
-          <a:xfrm>
-            <a:off x="889000" y="5219700"/>
+          <p:cNvPr id="68" name="TextBox 67"/>
+          <p:cNvSpPr txBox="1"/>
+          <p:nvPr/>
+        </p:nvSpPr>
+        <p:spPr>
+          <a:xfrm>
+            <a:off x="889000" y="5359019"/>
             <a:ext cx="10401300" cy="177800"/>
           </a:xfrm>
           <a:prstGeom prst="rect">
@@ -17444,13 +17888,13 @@
       </p:sp>
       <p:sp>
         <p:nvSpPr>
-          <p:cNvPr id="58" name="TextBox 57"/>
-          <p:cNvSpPr txBox="1"/>
-          <p:nvPr/>
-        </p:nvSpPr>
-        <p:spPr>
-          <a:xfrm>
-            <a:off x="889000" y="5448300"/>
+          <p:cNvPr id="69" name="TextBox 68"/>
+          <p:cNvSpPr txBox="1"/>
+          <p:nvPr/>
+        </p:nvSpPr>
+        <p:spPr>
+          <a:xfrm>
+            <a:off x="889000" y="5587619"/>
             <a:ext cx="10401300" cy="325120"/>
           </a:xfrm>
           <a:prstGeom prst="rect">
@@ -43250,7 +43694,7 @@
                 </a:solidFill>
                 <a:latin typeface="Calibri"/>
               </a:rPr>
-              <a:t>the React SPA, a served management API of 490 route declarations across 48 modules, a thin Python SDK and CLI over that contract, and the Aria copilot's permissioned agentic tool loop</a:t>
+              <a:t>the React SPA, a served management API of 570 route declarations across 64 modules, a thin Python SDK and CLI over that contract, and the Aria copilot's permissioned agentic tool loop</a:t>
             </a:r>
           </a:p>
         </p:txBody>
@@ -43902,7 +44346,7 @@
                 </a:solidFill>
                 <a:latin typeface="Calibri"/>
               </a:rPr>
-              <a:t>the modular services built at application startup; 77 ORM models and 263 schemas. The only tier that touches state or external systems</a:t>
+              <a:t>the modular services built at application startup; 112 ORM models and 347 schemas. The only tier that touches state or external systems</a:t>
             </a:r>
           </a:p>
         </p:txBody>
@@ -44065,7 +44509,7 @@
                 </a:solidFill>
                 <a:latin typeface="Calibri"/>
               </a:rPr>
-              <a:t>PostgreSQL, object storage, MLflow, providers — all of it swappable by configuration; 86 migrations</a:t>
+              <a:t>PostgreSQL, object storage, MLflow, providers — all of it swappable by configuration; 113 migrations</a:t>
             </a:r>
           </a:p>
         </p:txBody>
@@ -44487,7 +44931,7 @@
                 </a:solidFill>
                 <a:latin typeface="Calibri"/>
               </a:rPr>
-              <a:t>Queued work is drained by up to nine in-process loops arbitrated by claim and lease columns. One deployable, no split-brain — and loop capacity coupled to request capacity.</a:t>
+              <a:t>Queued work is drained by up to ten in-process loops arbitrated by claim and lease columns. One deployable, no split-brain — and loop capacity coupled to request capacity.</a:t>
             </a:r>
           </a:p>
         </p:txBody>

</xml_diff>